<commit_message>
Presentation: refresh live-server figures (full 2023 ARGO window)
Co-Authored-By: Claude Fable 5.1 <noreply@anthropic.com>
</commit_message>
<xml_diff>
--- a/presentation/FloatChat-Presentation.pptx
+++ b/presentation/FloatChat-Presentation.pptx
@@ -129,21 +129,21 @@
   <p:extLst>
     <p:ext uri="{521415D9-36F7-43E2-AB2F-B90AF26B5E84}">
       <p14:sectionLst xmlns:p14="http://schemas.microsoft.com/office/powerpoint/2010/main">
-        <p14:section name="Introduction" id="{d71d1925-e196-9a6e-9cba-d6ba52196175}">
+        <p14:section name="Introduction" id="{7443a9d0-c4ec-ac5b-cb75-803b06b5a815}">
           <p14:sldIdLst>
             <p14:sldId id="256"/>
             <p14:sldId id="257"/>
             <p14:sldId id="258"/>
           </p14:sldIdLst>
         </p14:section>
-        <p14:section name="What it does" id="{0a68dc06-97b7-928d-171a-3ca166d56783}">
+        <p14:section name="What it does" id="{246c3c83-f51e-5982-c15a-abf603b9ce5e}">
           <p14:sldIdLst>
             <p14:sldId id="259"/>
             <p14:sldId id="260"/>
             <p14:sldId id="261"/>
           </p14:sldIdLst>
         </p14:section>
-        <p14:section name="How it is built" id="{02c3156b-5ae1-1a9e-8d7e-127fcb42fb17}">
+        <p14:section name="How it is built" id="{7a8a4544-a23f-dd38-3d7d-eed0570cdd3d}">
           <p14:sldIdLst>
             <p14:sldId id="262"/>
             <p14:sldId id="263"/>
@@ -155,7 +155,7 @@
             <p14:sldId id="269"/>
           </p14:sldIdLst>
         </p14:section>
-        <p14:section name="Demonstration" id="{15ff8a7d-3dbe-8bb7-bbfb-2364e0d1078c}">
+        <p14:section name="Demonstration" id="{4487db2e-3f43-d5c9-9166-99b0e75a0452}">
           <p14:sldIdLst>
             <p14:sldId id="270"/>
             <p14:sldId id="271"/>
@@ -165,7 +165,7 @@
             <p14:sldId id="275"/>
           </p14:sldIdLst>
         </p14:section>
-        <p14:section name="Reflection" id="{b3d4d08b-4544-c4a3-4a06-8b4182385620}">
+        <p14:section name="Reflection" id="{41538084-28ba-1bd4-dc60-7788ee17998c}">
           <p14:sldIdLst>
             <p14:sldId id="276"/>
             <p14:sldId id="277"/>
@@ -8764,7 +8764,7 @@
                   <a:schemeClr val="tx1"/>
                 </a:solidFill>
               </a:rPr>
-              <a:t>5,299</a:t>
+              <a:t>12,318</a:t>
             </a:r>
             <a:endParaRPr lang="en-US" sz="2400" dirty="0"/>
           </a:p>
@@ -8836,7 +8836,7 @@
                   <a:schemeClr val="tx1"/>
                 </a:solidFill>
               </a:rPr>
-              <a:t>3.6 M</a:t>
+              <a:t>8.5 M</a:t>
             </a:r>
             <a:endParaRPr lang="en-US" sz="2400" dirty="0"/>
           </a:p>
@@ -9052,7 +9052,7 @@
                   <a:schemeClr val="tx2"/>
                 </a:solidFill>
               </a:rPr>
-              <a:t>ARGO window: Jan 2023 – Nov 2023 · Indian Ocean</a:t>
+              <a:t>ARGO window: Jan 2023 – Dec 2023 · Indian Ocean</a:t>
             </a:r>
             <a:endParaRPr lang="en-US" sz="1050" dirty="0"/>
           </a:p>

</xml_diff>